<commit_message>
docs: add LDA design->tapeout resident watcher as hard evidence (summary docx + 16->18pg platform deck)
</commit_message>
<xml_diff>
--- a/fab-mes-平台介绍.pptx
+++ b/fab-mes-平台介绍.pptx
@@ -20,6 +20,7 @@
     <p:sldId id="265" r:id="rId10"/>
     <p:sldId id="266" r:id="rId11"/>
     <p:sldId id="272" r:id="rId22"/>
+    <p:sldId id="274" r:id="rId101"/>
     <p:sldId id="267" r:id="rId12"/>
     <p:sldId id="268" r:id="rId13"/>
     <p:sldId id="269" r:id="rId14"/>
@@ -9746,7 +9747,7 @@
       </p:sp>
       <p:pic>
         <p:nvPicPr>
-          <p:cNvPr id="5" name="Image 0" descr="preencoded.png">    </p:cNvPr>
+          <p:cNvPr id="5" name="Image 0" descr="preencoded.png"/>
           <p:cNvPicPr>
             <a:picLocks noChangeAspect="1"/>
           </p:cNvPicPr>
@@ -9883,6 +9884,847 @@
             </a:r>
             <a:endParaRPr lang="en-US" sz="1400" dirty="0"/>
           </a:p>
+        </p:txBody>
+      </p:sp>
+    </p:spTree>
+  </p:cSld>
+  <p:clrMapOvr>
+    <a:masterClrMapping/>
+  </p:clrMapOvr>
+</p:sld>
+</file>
+
+<file path=ppt/slides/slide18.xml><?xml version="1.0" encoding="utf-8"?>
+<p:sld xmlns:a="http://schemas.openxmlformats.org/drawingml/2006/main" xmlns:p="http://schemas.openxmlformats.org/presentationml/2006/main" xmlns:r="http://schemas.openxmlformats.org/officeDocument/2006/relationships">
+  <p:cSld>
+    <p:spTree>
+      <p:nvGrpSpPr>
+        <p:cNvPr id="1" name=""/>
+        <p:cNvGrpSpPr/>
+        <p:nvPr/>
+      </p:nvGrpSpPr>
+      <p:grpSpPr/>
+      <p:sp>
+        <p:nvSpPr>
+          <p:cNvPr id="40" name=""/>
+          <p:cNvSpPr/>
+          <p:nvPr/>
+        </p:nvSpPr>
+        <p:spPr>
+          <a:xfrm>
+            <a:off x="635000" y="406400"/>
+            <a:ext cx="10058400" cy="317500"/>
+          </a:xfrm>
+          <a:prstGeom prst="rect">
+            <a:avLst/>
+          </a:prstGeom>
+          <a:noFill/>
+          <a:ln>
+            <a:noFill/>
+          </a:ln>
+        </p:spPr>
+        <p:txBody>
+          <a:bodyPr/>
+          <a:p>
+            <a:pPr/>
+            <a:r>
+              <a:rPr lang="zh-CN" sz="1300">
+                <a:solidFill>
+                  <a:srgbClr val="16B8A6"/>
+                </a:solidFill>
+                <a:latin typeface="Trebuchet MS"/>
+                <a:ea typeface="Trebuchet MS"/>
+              </a:rPr>
+              <a:t>LDA 有机衔接 · 设计到流片自动触发</a:t>
+            </a:r>
+            <a:endParaRPr/>
+          </a:p>
+        </p:txBody>
+      </p:sp>
+      <p:sp>
+        <p:nvSpPr>
+          <p:cNvPr id="41" name=""/>
+          <p:cNvSpPr/>
+          <p:nvPr/>
+        </p:nvSpPr>
+        <p:spPr>
+          <a:xfrm>
+            <a:off x="635000" y="711200"/>
+            <a:ext cx="10972800" cy="736600"/>
+          </a:xfrm>
+          <a:prstGeom prst="rect">
+            <a:avLst/>
+          </a:prstGeom>
+          <a:noFill/>
+          <a:ln>
+            <a:noFill/>
+          </a:ln>
+        </p:spPr>
+        <p:txBody>
+          <a:bodyPr/>
+          <a:p>
+            <a:pPr/>
+            <a:r>
+              <a:rPr lang="zh-CN" sz="3000">
+                <a:solidFill>
+                  <a:srgbClr val="0B1F3A"/>
+                </a:solidFill>
+                <a:latin typeface="Trebuchet MS"/>
+                <a:ea typeface="Trebuchet MS"/>
+              </a:rPr>
+              <a:t>同机 LDA 设计就绪，即自动触发 fab-mes NPI 流片</a:t>
+            </a:r>
+            <a:endParaRPr/>
+          </a:p>
+        </p:txBody>
+      </p:sp>
+      <p:sp>
+        <p:nvSpPr>
+          <p:cNvPr id="42" name=""/>
+          <p:cNvSpPr/>
+          <p:nvPr/>
+        </p:nvSpPr>
+        <p:spPr>
+          <a:xfrm>
+            <a:off x="660400" y="2159000"/>
+            <a:ext cx="1422400" cy="1168400"/>
+          </a:xfrm>
+          <a:prstGeom prst="rect">
+            <a:avLst/>
+          </a:prstGeom>
+          <a:solidFill>
+            <a:srgbClr val="11294D"/>
+          </a:solidFill>
+          <a:ln w="19050">
+            <a:solidFill>
+              <a:srgbClr val="2E6FD6"/>
+            </a:solidFill>
+            <a:prstDash val="solid"/>
+          </a:ln>
+        </p:spPr>
+        <p:txBody>
+          <a:bodyPr/>
+          <a:p>
+            <a:pPr/>
+            <a:r>
+              <a:rPr lang="zh-CN" sz="1100">
+                <a:solidFill>
+                  <a:srgbClr val="FFFFFF"/>
+                </a:solidFill>
+                <a:latin typeface="Calibri"/>
+                <a:ea typeface="Calibri"/>
+              </a:rPr>
+              <a:t>① LDA 设计系统</a:t>
+            </a:r>
+            <a:endParaRPr/>
+          </a:p>
+          <a:p>
+            <a:pPr/>
+            <a:r>
+              <a:rPr lang="zh-CN" sz="1100">
+                <a:solidFill>
+                  <a:srgbClr val="FFFFFF"/>
+                </a:solidFill>
+                <a:latin typeface="Calibri"/>
+                <a:ea typeface="Calibri"/>
+              </a:rPr>
+              <a:t>lda.weomnitech</a:t>
+            </a:r>
+            <a:endParaRPr/>
+          </a:p>
+          <a:p>
+            <a:pPr/>
+            <a:r>
+              <a:rPr lang="zh-CN" sz="1100">
+                <a:solidFill>
+                  <a:srgbClr val="FFFFFF"/>
+                </a:solidFill>
+                <a:latin typeface="Calibri"/>
+                <a:ea typeface="Calibri"/>
+              </a:rPr>
+              <a:t>光子·量子芯片设计</a:t>
+            </a:r>
+            <a:endParaRPr/>
+          </a:p>
+        </p:txBody>
+      </p:sp>
+      <p:sp>
+        <p:nvSpPr>
+          <p:cNvPr id="43" name=""/>
+          <p:cNvSpPr/>
+          <p:nvPr/>
+        </p:nvSpPr>
+        <p:spPr>
+          <a:xfrm>
+            <a:off x="2235200" y="2159000"/>
+            <a:ext cx="1422400" cy="1168400"/>
+          </a:xfrm>
+          <a:prstGeom prst="rect">
+            <a:avLst/>
+          </a:prstGeom>
+          <a:solidFill>
+            <a:srgbClr val="11294D"/>
+          </a:solidFill>
+          <a:ln w="19050">
+            <a:solidFill>
+              <a:srgbClr val="16B8A6"/>
+            </a:solidFill>
+            <a:prstDash val="solid"/>
+          </a:ln>
+        </p:spPr>
+        <p:txBody>
+          <a:bodyPr/>
+          <a:p>
+            <a:pPr/>
+            <a:r>
+              <a:rPr lang="zh-CN" sz="1100">
+                <a:solidFill>
+                  <a:srgbClr val="FFFFFF"/>
+                </a:solidFill>
+                <a:latin typeface="Calibri"/>
+                <a:ea typeface="Calibri"/>
+              </a:rPr>
+              <a:t>② 设计就绪交付</a:t>
+            </a:r>
+            <a:endParaRPr/>
+          </a:p>
+          <a:p>
+            <a:pPr/>
+            <a:r>
+              <a:rPr lang="zh-CN" sz="1100">
+                <a:solidFill>
+                  <a:srgbClr val="FFFFFF"/>
+                </a:solidFill>
+                <a:latin typeface="Calibri"/>
+                <a:ea typeface="Calibri"/>
+              </a:rPr>
+              <a:t>package.ready</a:t>
+            </a:r>
+            <a:endParaRPr/>
+          </a:p>
+          <a:p>
+            <a:pPr/>
+            <a:r>
+              <a:rPr lang="zh-CN" sz="1100">
+                <a:solidFill>
+                  <a:srgbClr val="FFFFFF"/>
+                </a:solidFill>
+                <a:latin typeface="Calibri"/>
+                <a:ea typeface="Calibri"/>
+              </a:rPr>
+              <a:t>verification 验证门</a:t>
+            </a:r>
+            <a:endParaRPr/>
+          </a:p>
+        </p:txBody>
+      </p:sp>
+      <p:sp>
+        <p:nvSpPr>
+          <p:cNvPr id="44" name=""/>
+          <p:cNvSpPr/>
+          <p:nvPr/>
+        </p:nvSpPr>
+        <p:spPr>
+          <a:xfrm>
+            <a:off x="3810000" y="2159000"/>
+            <a:ext cx="1422400" cy="1168400"/>
+          </a:xfrm>
+          <a:prstGeom prst="rect">
+            <a:avLst/>
+          </a:prstGeom>
+          <a:solidFill>
+            <a:srgbClr val="11294D"/>
+          </a:solidFill>
+          <a:ln w="19050">
+            <a:solidFill>
+              <a:srgbClr val="16B8A6"/>
+            </a:solidFill>
+            <a:prstDash val="solid"/>
+          </a:ln>
+        </p:spPr>
+        <p:txBody>
+          <a:bodyPr/>
+          <a:p>
+            <a:pPr/>
+            <a:r>
+              <a:rPr lang="zh-CN" sz="1100">
+                <a:solidFill>
+                  <a:srgbClr val="FFFFFF"/>
+                </a:solidFill>
+                <a:latin typeface="Calibri"/>
+                <a:ea typeface="Calibri"/>
+              </a:rPr>
+              <a:t>③ 常驻看门狗</a:t>
+            </a:r>
+            <a:endParaRPr/>
+          </a:p>
+          <a:p>
+            <a:pPr/>
+            <a:r>
+              <a:rPr lang="zh-CN" sz="1100">
+                <a:solidFill>
+                  <a:srgbClr val="FFFFFF"/>
+                </a:solidFill>
+                <a:latin typeface="Calibri"/>
+                <a:ea typeface="Calibri"/>
+              </a:rPr>
+              <a:t>每 20s 轮询</a:t>
+            </a:r>
+            <a:endParaRPr/>
+          </a:p>
+          <a:p>
+            <a:pPr/>
+            <a:r>
+              <a:rPr lang="zh-CN" sz="1100">
+                <a:solidFill>
+                  <a:srgbClr val="FFFFFF"/>
+                </a:solidFill>
+                <a:latin typeface="Calibri"/>
+                <a:ea typeface="Calibri"/>
+              </a:rPr>
+              <a:t>自动触发 NPI</a:t>
+            </a:r>
+            <a:endParaRPr/>
+          </a:p>
+        </p:txBody>
+      </p:sp>
+      <p:sp>
+        <p:nvSpPr>
+          <p:cNvPr id="45" name=""/>
+          <p:cNvSpPr/>
+          <p:nvPr/>
+        </p:nvSpPr>
+        <p:spPr>
+          <a:xfrm>
+            <a:off x="5384800" y="2159000"/>
+            <a:ext cx="1422400" cy="1168400"/>
+          </a:xfrm>
+          <a:prstGeom prst="rect">
+            <a:avLst/>
+          </a:prstGeom>
+          <a:solidFill>
+            <a:srgbClr val="11294D"/>
+          </a:solidFill>
+          <a:ln w="19050">
+            <a:solidFill>
+              <a:srgbClr val="F2B544"/>
+            </a:solidFill>
+            <a:prstDash val="solid"/>
+          </a:ln>
+        </p:spPr>
+        <p:txBody>
+          <a:bodyPr/>
+          <a:p>
+            <a:pPr/>
+            <a:r>
+              <a:rPr lang="zh-CN" sz="1100">
+                <a:solidFill>
+                  <a:srgbClr val="FFFFFF"/>
+                </a:solidFill>
+                <a:latin typeface="Calibri"/>
+                <a:ea typeface="Calibri"/>
+              </a:rPr>
+              <a:t>④ 设计档案+光罩</a:t>
+            </a:r>
+            <a:endParaRPr/>
+          </a:p>
+          <a:p>
+            <a:pPr/>
+            <a:r>
+              <a:rPr lang="zh-CN" sz="1100">
+                <a:solidFill>
+                  <a:srgbClr val="FFFFFF"/>
+                </a:solidFill>
+                <a:latin typeface="Calibri"/>
+                <a:ea typeface="Calibri"/>
+              </a:rPr>
+              <a:t>fab-mes 落库</a:t>
+            </a:r>
+            <a:endParaRPr/>
+          </a:p>
+          <a:p>
+            <a:pPr/>
+            <a:r>
+              <a:rPr lang="zh-CN" sz="1100">
+                <a:solidFill>
+                  <a:srgbClr val="FFFFFF"/>
+                </a:solidFill>
+                <a:latin typeface="Calibri"/>
+                <a:ea typeface="Calibri"/>
+              </a:rPr>
+              <a:t>layers→passes 派生</a:t>
+            </a:r>
+            <a:endParaRPr/>
+          </a:p>
+        </p:txBody>
+      </p:sp>
+      <p:sp>
+        <p:nvSpPr>
+          <p:cNvPr id="46" name=""/>
+          <p:cNvSpPr/>
+          <p:nvPr/>
+        </p:nvSpPr>
+        <p:spPr>
+          <a:xfrm>
+            <a:off x="6959600" y="2159000"/>
+            <a:ext cx="1422400" cy="1168400"/>
+          </a:xfrm>
+          <a:prstGeom prst="rect">
+            <a:avLst/>
+          </a:prstGeom>
+          <a:solidFill>
+            <a:srgbClr val="11294D"/>
+          </a:solidFill>
+          <a:ln w="19050">
+            <a:solidFill>
+              <a:srgbClr val="2E6FD6"/>
+            </a:solidFill>
+            <a:prstDash val="solid"/>
+          </a:ln>
+        </p:spPr>
+        <p:txBody>
+          <a:bodyPr/>
+          <a:p>
+            <a:pPr/>
+            <a:r>
+              <a:rPr lang="zh-CN" sz="1100">
+                <a:solidFill>
+                  <a:srgbClr val="FFFFFF"/>
+                </a:solidFill>
+                <a:latin typeface="Calibri"/>
+                <a:ea typeface="Calibri"/>
+              </a:rPr>
+              <a:t>⑤ NPI 流片批</a:t>
+            </a:r>
+            <a:endParaRPr/>
+          </a:p>
+          <a:p>
+            <a:pPr/>
+            <a:r>
+              <a:rPr lang="zh-CN" sz="1100">
+                <a:solidFill>
+                  <a:srgbClr val="FFFFFF"/>
+                </a:solidFill>
+                <a:latin typeface="Calibri"/>
+                <a:ea typeface="Calibri"/>
+              </a:rPr>
+              <a:t>WO + tapeout</a:t>
+            </a:r>
+            <a:endParaRPr/>
+          </a:p>
+          <a:p>
+            <a:r>
+              <a:t>主轴 WIP 流转</a:t>
+            </a:r>
+          </a:p>
+        </p:txBody>
+      </p:sp>
+      <p:sp>
+        <p:nvSpPr>
+          <p:cNvPr id="47" name=""/>
+          <p:cNvSpPr/>
+          <p:nvPr/>
+        </p:nvSpPr>
+        <p:spPr>
+          <a:xfrm>
+            <a:off x="8534400" y="2159000"/>
+            <a:ext cx="1422400" cy="1168400"/>
+          </a:xfrm>
+          <a:prstGeom prst="rect">
+            <a:avLst/>
+          </a:prstGeom>
+          <a:solidFill>
+            <a:srgbClr val="11294D"/>
+          </a:solidFill>
+          <a:ln w="19050">
+            <a:solidFill>
+              <a:srgbClr val="F2B544"/>
+            </a:solidFill>
+            <a:prstDash val="solid"/>
+          </a:ln>
+        </p:spPr>
+        <p:txBody>
+          <a:bodyPr/>
+          <a:p>
+            <a:pPr/>
+            <a:r>
+              <a:rPr lang="zh-CN" sz="1100">
+                <a:solidFill>
+                  <a:srgbClr val="FFFFFF"/>
+                </a:solidFill>
+                <a:latin typeface="Calibri"/>
+                <a:ea typeface="Calibri"/>
+              </a:rPr>
+              <a:t>⑥ 严格幂等</a:t>
+            </a:r>
+            <a:endParaRPr/>
+          </a:p>
+          <a:p>
+            <a:pPr/>
+            <a:r>
+              <a:rPr lang="zh-CN" sz="1100">
+                <a:solidFill>
+                  <a:srgbClr val="FFFFFF"/>
+                </a:solidFill>
+                <a:latin typeface="Calibri"/>
+                <a:ea typeface="Calibri"/>
+              </a:rPr>
+              <a:t>lda_sync 去重</a:t>
+            </a:r>
+            <a:endParaRPr/>
+          </a:p>
+          <a:p>
+            <a:pPr/>
+            <a:r>
+              <a:rPr lang="zh-CN" sz="1100">
+                <a:solidFill>
+                  <a:srgbClr val="FFFFFF"/>
+                </a:solidFill>
+                <a:latin typeface="Calibri"/>
+                <a:ea typeface="Calibri"/>
+              </a:rPr>
+              <a:t>重启不重复</a:t>
+            </a:r>
+            <a:endParaRPr/>
+          </a:p>
+        </p:txBody>
+      </p:sp>
+      <p:sp>
+        <p:nvSpPr>
+          <p:cNvPr id="48" name=""/>
+          <p:cNvSpPr/>
+          <p:nvPr/>
+        </p:nvSpPr>
+        <p:spPr>
+          <a:xfrm>
+            <a:off x="10109200" y="2159000"/>
+            <a:ext cx="1422400" cy="1168400"/>
+          </a:xfrm>
+          <a:prstGeom prst="rect">
+            <a:avLst/>
+          </a:prstGeom>
+          <a:solidFill>
+            <a:srgbClr val="11294D"/>
+          </a:solidFill>
+          <a:ln w="19050">
+            <a:solidFill>
+              <a:srgbClr val="E5573E"/>
+            </a:solidFill>
+            <a:prstDash val="solid"/>
+          </a:ln>
+        </p:spPr>
+        <p:txBody>
+          <a:bodyPr/>
+          <a:p>
+            <a:pPr/>
+            <a:r>
+              <a:rPr lang="zh-CN" sz="1100">
+                <a:solidFill>
+                  <a:srgbClr val="FFFFFF"/>
+                </a:solidFill>
+                <a:latin typeface="Calibri"/>
+                <a:ea typeface="Calibri"/>
+              </a:rPr>
+              <a:t>⑦ 自主可控</a:t>
+            </a:r>
+            <a:endParaRPr/>
+          </a:p>
+          <a:p>
+            <a:pPr/>
+            <a:r>
+              <a:rPr lang="zh-CN" sz="1100">
+                <a:solidFill>
+                  <a:srgbClr val="FFFFFF"/>
+                </a:solidFill>
+                <a:latin typeface="Calibri"/>
+                <a:ea typeface="Calibri"/>
+              </a:rPr>
+              <a:t>不绑定 EDA</a:t>
+            </a:r>
+            <a:endParaRPr/>
+          </a:p>
+          <a:p>
+            <a:pPr/>
+            <a:r>
+              <a:rPr lang="zh-CN" sz="1100">
+                <a:solidFill>
+                  <a:srgbClr val="FFFFFF"/>
+                </a:solidFill>
+                <a:latin typeface="Calibri"/>
+                <a:ea typeface="Calibri"/>
+              </a:rPr>
+              <a:t>主线向上游延伸</a:t>
+            </a:r>
+            <a:endParaRPr/>
+          </a:p>
+        </p:txBody>
+      </p:sp>
+      <p:sp>
+        <p:nvSpPr>
+          <p:cNvPr id="49" name=""/>
+          <p:cNvSpPr/>
+          <p:nvPr/>
+        </p:nvSpPr>
+        <p:spPr>
+          <a:xfrm>
+            <a:off x="660400" y="3962400"/>
+            <a:ext cx="10871200" cy="304800"/>
+          </a:xfrm>
+          <a:prstGeom prst="rect">
+            <a:avLst/>
+          </a:prstGeom>
+          <a:noFill/>
+          <a:ln>
+            <a:noFill/>
+          </a:ln>
+        </p:spPr>
+        <p:txBody>
+          <a:bodyPr/>
+          <a:p>
+            <a:pPr/>
+            <a:r>
+              <a:rPr lang="zh-CN" sz="1200">
+                <a:solidFill>
+                  <a:srgbClr val="0B1F3A"/>
+                </a:solidFill>
+                <a:latin typeface="Calibri"/>
+                <a:ea typeface="Calibri"/>
+              </a:rPr>
+              <a:t>↑ 50 个已验证 LDA 设计自动接入，生成 WO/tapeout lot 在 MES 主轴 WIP 流转，重复扫描 0 新建、0 漏网。</a:t>
+            </a:r>
+            <a:endParaRPr/>
+          </a:p>
+        </p:txBody>
+      </p:sp>
+      <p:sp>
+        <p:nvSpPr>
+          <p:cNvPr id="50" name=""/>
+          <p:cNvSpPr/>
+          <p:nvPr/>
+        </p:nvSpPr>
+        <p:spPr>
+          <a:xfrm>
+            <a:off x="660400" y="4419600"/>
+            <a:ext cx="10871200" cy="736600"/>
+          </a:xfrm>
+          <a:prstGeom prst="rect">
+            <a:avLst/>
+          </a:prstGeom>
+          <a:noFill/>
+          <a:ln>
+            <a:noFill/>
+          </a:ln>
+        </p:spPr>
+        <p:txBody>
+          <a:bodyPr/>
+          <a:p>
+            <a:pPr/>
+            <a:r>
+              <a:rPr lang="zh-CN" sz="1100">
+                <a:solidFill>
+                  <a:srgbClr val="5B6B7E"/>
+                </a:solidFill>
+                <a:latin typeface="Calibri"/>
+                <a:ea typeface="Calibri"/>
+              </a:rPr>
+              <a:t>fab-mes 反向成为 LDA 设计的下游「可制造性/验证」证明；不绑定任何第三方商业 EDA/设计套装。</a:t>
+            </a:r>
+            <a:endParaRPr/>
+          </a:p>
+        </p:txBody>
+      </p:sp>
+      <p:sp>
+        <p:nvSpPr>
+          <p:cNvPr id="51" name=""/>
+          <p:cNvSpPr/>
+          <p:nvPr/>
+        </p:nvSpPr>
+        <p:spPr>
+          <a:xfrm>
+            <a:off x="660400" y="3784600"/>
+            <a:ext cx="10871200" cy="101600"/>
+          </a:xfrm>
+          <a:prstGeom prst="rect">
+            <a:avLst/>
+          </a:prstGeom>
+          <a:solidFill>
+            <a:srgbClr val="16B8A6"/>
+          </a:solidFill>
+          <a:ln>
+            <a:noFill/>
+          </a:ln>
+        </p:spPr>
+        <p:txBody>
+          <a:bodyPr/>
+          <a:p/>
+        </p:txBody>
+      </p:sp>
+      <p:sp>
+        <p:nvSpPr>
+          <p:cNvPr id="52" name=""/>
+          <p:cNvSpPr/>
+          <p:nvPr/>
+        </p:nvSpPr>
+        <p:spPr>
+          <a:xfrm>
+            <a:off x="2082800" y="2743200"/>
+            <a:ext cx="152400" cy="0"/>
+          </a:xfrm>
+          <a:prstGeom prst="line">
+            <a:avLst/>
+          </a:prstGeom>
+          <a:noFill/>
+          <a:ln w="25400">
+            <a:solidFill>
+              <a:srgbClr val="16B8A6"/>
+            </a:solidFill>
+            <a:prstDash val="solid"/>
+            <a:tailEnd type="triangle"/>
+          </a:ln>
+        </p:spPr>
+        <p:txBody>
+          <a:bodyPr/>
+          <a:p/>
+        </p:txBody>
+      </p:sp>
+      <p:sp>
+        <p:nvSpPr>
+          <p:cNvPr id="53" name=""/>
+          <p:cNvSpPr/>
+          <p:nvPr/>
+        </p:nvSpPr>
+        <p:spPr>
+          <a:xfrm>
+            <a:off x="3657600" y="2743200"/>
+            <a:ext cx="152400" cy="0"/>
+          </a:xfrm>
+          <a:prstGeom prst="line">
+            <a:avLst/>
+          </a:prstGeom>
+          <a:noFill/>
+          <a:ln w="25400">
+            <a:solidFill>
+              <a:srgbClr val="16B8A6"/>
+            </a:solidFill>
+            <a:prstDash val="solid"/>
+            <a:tailEnd type="triangle"/>
+          </a:ln>
+        </p:spPr>
+        <p:txBody>
+          <a:bodyPr/>
+          <a:p/>
+        </p:txBody>
+      </p:sp>
+      <p:sp>
+        <p:nvSpPr>
+          <p:cNvPr id="54" name=""/>
+          <p:cNvSpPr/>
+          <p:nvPr/>
+        </p:nvSpPr>
+        <p:spPr>
+          <a:xfrm>
+            <a:off x="5232400" y="2743200"/>
+            <a:ext cx="152400" cy="0"/>
+          </a:xfrm>
+          <a:prstGeom prst="line">
+            <a:avLst/>
+          </a:prstGeom>
+          <a:noFill/>
+          <a:ln w="25400">
+            <a:solidFill>
+              <a:srgbClr val="16B8A6"/>
+            </a:solidFill>
+            <a:prstDash val="solid"/>
+            <a:tailEnd type="triangle"/>
+          </a:ln>
+        </p:spPr>
+        <p:txBody>
+          <a:bodyPr/>
+          <a:p/>
+        </p:txBody>
+      </p:sp>
+      <p:sp>
+        <p:nvSpPr>
+          <p:cNvPr id="55" name=""/>
+          <p:cNvSpPr/>
+          <p:nvPr/>
+        </p:nvSpPr>
+        <p:spPr>
+          <a:xfrm>
+            <a:off x="6807200" y="2743200"/>
+            <a:ext cx="152400" cy="0"/>
+          </a:xfrm>
+          <a:prstGeom prst="line">
+            <a:avLst/>
+          </a:prstGeom>
+          <a:noFill/>
+          <a:ln w="25400">
+            <a:solidFill>
+              <a:srgbClr val="16B8A6"/>
+            </a:solidFill>
+            <a:prstDash val="solid"/>
+            <a:tailEnd type="triangle"/>
+          </a:ln>
+        </p:spPr>
+        <p:txBody>
+          <a:bodyPr/>
+          <a:p/>
+        </p:txBody>
+      </p:sp>
+      <p:sp>
+        <p:nvSpPr>
+          <p:cNvPr id="56" name=""/>
+          <p:cNvSpPr/>
+          <p:nvPr/>
+        </p:nvSpPr>
+        <p:spPr>
+          <a:xfrm>
+            <a:off x="8382000" y="2743200"/>
+            <a:ext cx="152400" cy="0"/>
+          </a:xfrm>
+          <a:prstGeom prst="line">
+            <a:avLst/>
+          </a:prstGeom>
+          <a:noFill/>
+          <a:ln w="25400">
+            <a:solidFill>
+              <a:srgbClr val="16B8A6"/>
+            </a:solidFill>
+            <a:prstDash val="solid"/>
+            <a:tailEnd type="triangle"/>
+          </a:ln>
+        </p:spPr>
+        <p:txBody>
+          <a:bodyPr/>
+          <a:p/>
+        </p:txBody>
+      </p:sp>
+      <p:sp>
+        <p:nvSpPr>
+          <p:cNvPr id="57" name=""/>
+          <p:cNvSpPr/>
+          <p:nvPr/>
+        </p:nvSpPr>
+        <p:spPr>
+          <a:xfrm>
+            <a:off x="9956800" y="2743200"/>
+            <a:ext cx="152400" cy="0"/>
+          </a:xfrm>
+          <a:prstGeom prst="line">
+            <a:avLst/>
+          </a:prstGeom>
+          <a:noFill/>
+          <a:ln w="25400">
+            <a:solidFill>
+              <a:srgbClr val="16B8A6"/>
+            </a:solidFill>
+            <a:prstDash val="solid"/>
+            <a:tailEnd type="triangle"/>
+          </a:ln>
+        </p:spPr>
+        <p:txBody>
+          <a:bodyPr/>
+          <a:p/>
         </p:txBody>
       </p:sp>
     </p:spTree>

</xml_diff>